<commit_message>
feat: live examples, lite fixes, embeddings, coverage and limits
</commit_message>
<xml_diff>
--- a/examples/tk1/presentation_tk1.pptx
+++ b/examples/tk1/presentation_tk1.pptx
@@ -6,6 +6,15 @@
   </p:sldMasterIdLst>
   <p:sldIdLst>
     <p:sldId id="256" r:id="rId7"/>
+    <p:sldId id="257" r:id="rId9"/>
+    <p:sldId id="258" r:id="rId10"/>
+    <p:sldId id="259" r:id="rId11"/>
+    <p:sldId id="260" r:id="rId12"/>
+    <p:sldId id="261" r:id="rId13"/>
+    <p:sldId id="262" r:id="rId14"/>
+    <p:sldId id="263" r:id="rId15"/>
+    <p:sldId id="264" r:id="rId16"/>
+    <p:sldId id="265" r:id="rId17"/>
   </p:sldIdLst>
   <p:sldSz cx="9144000" cy="6858000" type="screen4x3"/>
   <p:notesSz cx="6858000" cy="9144000"/>
@@ -502,7 +511,637 @@
           <a:lstStyle/>
           <a:p>
             <a:r>
-              <a:t>Сгенерируйте слайды навыком S13 (GigaChat) перед выгрузкой.</a:t>
+              <a:t>Кратко рассказать о сферах применения Python. Показать, что язык подходит для новичков и профессионалов.</a:t>
+            </a:r>
+          </a:p>
+        </p:txBody>
+      </p:sp>
+      <p:sp>
+        <p:nvSpPr>
+          <p:cNvPr id="4" name="Slide Number Placeholder 3"/>
+          <p:cNvSpPr>
+            <a:spLocks noGrp="1"/>
+          </p:cNvSpPr>
+          <p:nvPr>
+            <p:ph type="sldNum" idx="5" sz="quarter"/>
+          </p:nvPr>
+        </p:nvSpPr>
+        <p:spPr/>
+      </p:sp>
+    </p:spTree>
+  </p:cSld>
+  <p:clrMapOvr>
+    <a:masterClrMapping/>
+  </p:clrMapOvr>
+</p:notes>
+</file>
+
+<file path=ppt/notesSlides/notesSlide10.xml><?xml version="1.0" encoding="utf-8"?>
+<p:notes xmlns:a="http://schemas.openxmlformats.org/drawingml/2006/main" xmlns:p="http://schemas.openxmlformats.org/presentationml/2006/main" xmlns:r="http://schemas.openxmlformats.org/officeDocument/2006/relationships">
+  <p:cSld>
+    <p:spTree>
+      <p:nvGrpSpPr>
+        <p:cNvPr id="1" name=""/>
+        <p:cNvGrpSpPr/>
+        <p:nvPr/>
+      </p:nvGrpSpPr>
+      <p:grpSpPr>
+        <a:xfrm>
+          <a:off x="0" y="0"/>
+          <a:ext cx="0" cy="0"/>
+          <a:chOff x="0" y="0"/>
+          <a:chExt cx="0" cy="0"/>
+        </a:xfrm>
+      </p:grpSpPr>
+      <p:sp>
+        <p:nvSpPr>
+          <p:cNvPr id="2" name="Slide Image Placeholder 1"/>
+          <p:cNvSpPr>
+            <a:spLocks noGrp="1"/>
+          </p:cNvSpPr>
+          <p:nvPr>
+            <p:ph type="sldImg" idx="2"/>
+          </p:nvPr>
+        </p:nvSpPr>
+        <p:spPr/>
+      </p:sp>
+      <p:sp>
+        <p:nvSpPr>
+          <p:cNvPr id="3" name="Notes Placeholder 2"/>
+          <p:cNvSpPr>
+            <a:spLocks noGrp="1"/>
+          </p:cNvSpPr>
+          <p:nvPr>
+            <p:ph type="body" idx="3" sz="quarter"/>
+          </p:nvPr>
+        </p:nvSpPr>
+        <p:spPr/>
+        <p:txBody>
+          <a:bodyPr/>
+          <a:lstStyle/>
+          <a:p>
+            <a:r>
+              <a:t>Дать задания для закрепления материала.</a:t>
+            </a:r>
+          </a:p>
+        </p:txBody>
+      </p:sp>
+      <p:sp>
+        <p:nvSpPr>
+          <p:cNvPr id="4" name="Slide Number Placeholder 3"/>
+          <p:cNvSpPr>
+            <a:spLocks noGrp="1"/>
+          </p:cNvSpPr>
+          <p:nvPr>
+            <p:ph type="sldNum" idx="5" sz="quarter"/>
+          </p:nvPr>
+        </p:nvSpPr>
+        <p:spPr/>
+      </p:sp>
+    </p:spTree>
+  </p:cSld>
+  <p:clrMapOvr>
+    <a:masterClrMapping/>
+  </p:clrMapOvr>
+</p:notes>
+</file>
+
+<file path=ppt/notesSlides/notesSlide2.xml><?xml version="1.0" encoding="utf-8"?>
+<p:notes xmlns:a="http://schemas.openxmlformats.org/drawingml/2006/main" xmlns:p="http://schemas.openxmlformats.org/presentationml/2006/main" xmlns:r="http://schemas.openxmlformats.org/officeDocument/2006/relationships">
+  <p:cSld>
+    <p:spTree>
+      <p:nvGrpSpPr>
+        <p:cNvPr id="1" name=""/>
+        <p:cNvGrpSpPr/>
+        <p:nvPr/>
+      </p:nvGrpSpPr>
+      <p:grpSpPr>
+        <a:xfrm>
+          <a:off x="0" y="0"/>
+          <a:ext cx="0" cy="0"/>
+          <a:chOff x="0" y="0"/>
+          <a:chExt cx="0" cy="0"/>
+        </a:xfrm>
+      </p:grpSpPr>
+      <p:sp>
+        <p:nvSpPr>
+          <p:cNvPr id="2" name="Slide Image Placeholder 1"/>
+          <p:cNvSpPr>
+            <a:spLocks noGrp="1"/>
+          </p:cNvSpPr>
+          <p:nvPr>
+            <p:ph type="sldImg" idx="2"/>
+          </p:nvPr>
+        </p:nvSpPr>
+        <p:spPr/>
+      </p:sp>
+      <p:sp>
+        <p:nvSpPr>
+          <p:cNvPr id="3" name="Notes Placeholder 2"/>
+          <p:cNvSpPr>
+            <a:spLocks noGrp="1"/>
+          </p:cNvSpPr>
+          <p:nvPr>
+            <p:ph type="body" idx="3" sz="quarter"/>
+          </p:nvPr>
+        </p:nvSpPr>
+        <p:spPr/>
+        <p:txBody>
+          <a:bodyPr/>
+          <a:lstStyle/>
+          <a:p>
+            <a:r>
+              <a:t>Показать, как выглядит первая программа и как её запустить.</a:t>
+            </a:r>
+          </a:p>
+        </p:txBody>
+      </p:sp>
+      <p:sp>
+        <p:nvSpPr>
+          <p:cNvPr id="4" name="Slide Number Placeholder 3"/>
+          <p:cNvSpPr>
+            <a:spLocks noGrp="1"/>
+          </p:cNvSpPr>
+          <p:nvPr>
+            <p:ph type="sldNum" idx="5" sz="quarter"/>
+          </p:nvPr>
+        </p:nvSpPr>
+        <p:spPr/>
+      </p:sp>
+    </p:spTree>
+  </p:cSld>
+  <p:clrMapOvr>
+    <a:masterClrMapping/>
+  </p:clrMapOvr>
+</p:notes>
+</file>
+
+<file path=ppt/notesSlides/notesSlide3.xml><?xml version="1.0" encoding="utf-8"?>
+<p:notes xmlns:a="http://schemas.openxmlformats.org/drawingml/2006/main" xmlns:p="http://schemas.openxmlformats.org/presentationml/2006/main" xmlns:r="http://schemas.openxmlformats.org/officeDocument/2006/relationships">
+  <p:cSld>
+    <p:spTree>
+      <p:nvGrpSpPr>
+        <p:cNvPr id="1" name=""/>
+        <p:cNvGrpSpPr/>
+        <p:nvPr/>
+      </p:nvGrpSpPr>
+      <p:grpSpPr>
+        <a:xfrm>
+          <a:off x="0" y="0"/>
+          <a:ext cx="0" cy="0"/>
+          <a:chOff x="0" y="0"/>
+          <a:chExt cx="0" cy="0"/>
+        </a:xfrm>
+      </p:grpSpPr>
+      <p:sp>
+        <p:nvSpPr>
+          <p:cNvPr id="2" name="Slide Image Placeholder 1"/>
+          <p:cNvSpPr>
+            <a:spLocks noGrp="1"/>
+          </p:cNvSpPr>
+          <p:nvPr>
+            <p:ph type="sldImg" idx="2"/>
+          </p:nvPr>
+        </p:nvSpPr>
+        <p:spPr/>
+      </p:sp>
+      <p:sp>
+        <p:nvSpPr>
+          <p:cNvPr id="3" name="Notes Placeholder 2"/>
+          <p:cNvSpPr>
+            <a:spLocks noGrp="1"/>
+          </p:cNvSpPr>
+          <p:nvPr>
+            <p:ph type="body" idx="3" sz="quarter"/>
+          </p:nvPr>
+        </p:nvSpPr>
+        <p:spPr/>
+        <p:txBody>
+          <a:bodyPr/>
+          <a:lstStyle/>
+          <a:p>
+            <a:r>
+              <a:t>Объяснить, как объявлять переменные и какие типы данных бывают.</a:t>
+            </a:r>
+          </a:p>
+        </p:txBody>
+      </p:sp>
+      <p:sp>
+        <p:nvSpPr>
+          <p:cNvPr id="4" name="Slide Number Placeholder 3"/>
+          <p:cNvSpPr>
+            <a:spLocks noGrp="1"/>
+          </p:cNvSpPr>
+          <p:nvPr>
+            <p:ph type="sldNum" idx="5" sz="quarter"/>
+          </p:nvPr>
+        </p:nvSpPr>
+        <p:spPr/>
+      </p:sp>
+    </p:spTree>
+  </p:cSld>
+  <p:clrMapOvr>
+    <a:masterClrMapping/>
+  </p:clrMapOvr>
+</p:notes>
+</file>
+
+<file path=ppt/notesSlides/notesSlide4.xml><?xml version="1.0" encoding="utf-8"?>
+<p:notes xmlns:a="http://schemas.openxmlformats.org/drawingml/2006/main" xmlns:p="http://schemas.openxmlformats.org/presentationml/2006/main" xmlns:r="http://schemas.openxmlformats.org/officeDocument/2006/relationships">
+  <p:cSld>
+    <p:spTree>
+      <p:nvGrpSpPr>
+        <p:cNvPr id="1" name=""/>
+        <p:cNvGrpSpPr/>
+        <p:nvPr/>
+      </p:nvGrpSpPr>
+      <p:grpSpPr>
+        <a:xfrm>
+          <a:off x="0" y="0"/>
+          <a:ext cx="0" cy="0"/>
+          <a:chOff x="0" y="0"/>
+          <a:chExt cx="0" cy="0"/>
+        </a:xfrm>
+      </p:grpSpPr>
+      <p:sp>
+        <p:nvSpPr>
+          <p:cNvPr id="2" name="Slide Image Placeholder 1"/>
+          <p:cNvSpPr>
+            <a:spLocks noGrp="1"/>
+          </p:cNvSpPr>
+          <p:nvPr>
+            <p:ph type="sldImg" idx="2"/>
+          </p:nvPr>
+        </p:nvSpPr>
+        <p:spPr/>
+      </p:sp>
+      <p:sp>
+        <p:nvSpPr>
+          <p:cNvPr id="3" name="Notes Placeholder 2"/>
+          <p:cNvSpPr>
+            <a:spLocks noGrp="1"/>
+          </p:cNvSpPr>
+          <p:nvPr>
+            <p:ph type="body" idx="3" sz="quarter"/>
+          </p:nvPr>
+        </p:nvSpPr>
+        <p:spPr/>
+        <p:txBody>
+          <a:bodyPr/>
+          <a:lstStyle/>
+          <a:p>
+            <a:r>
+              <a:t>Показать на примере, как программа взаимодействует с пользователем.</a:t>
+            </a:r>
+          </a:p>
+        </p:txBody>
+      </p:sp>
+      <p:sp>
+        <p:nvSpPr>
+          <p:cNvPr id="4" name="Slide Number Placeholder 3"/>
+          <p:cNvSpPr>
+            <a:spLocks noGrp="1"/>
+          </p:cNvSpPr>
+          <p:nvPr>
+            <p:ph type="sldNum" idx="5" sz="quarter"/>
+          </p:nvPr>
+        </p:nvSpPr>
+        <p:spPr/>
+      </p:sp>
+    </p:spTree>
+  </p:cSld>
+  <p:clrMapOvr>
+    <a:masterClrMapping/>
+  </p:clrMapOvr>
+</p:notes>
+</file>
+
+<file path=ppt/notesSlides/notesSlide5.xml><?xml version="1.0" encoding="utf-8"?>
+<p:notes xmlns:a="http://schemas.openxmlformats.org/drawingml/2006/main" xmlns:p="http://schemas.openxmlformats.org/presentationml/2006/main" xmlns:r="http://schemas.openxmlformats.org/officeDocument/2006/relationships">
+  <p:cSld>
+    <p:spTree>
+      <p:nvGrpSpPr>
+        <p:cNvPr id="1" name=""/>
+        <p:cNvGrpSpPr/>
+        <p:nvPr/>
+      </p:nvGrpSpPr>
+      <p:grpSpPr>
+        <a:xfrm>
+          <a:off x="0" y="0"/>
+          <a:ext cx="0" cy="0"/>
+          <a:chOff x="0" y="0"/>
+          <a:chExt cx="0" cy="0"/>
+        </a:xfrm>
+      </p:grpSpPr>
+      <p:sp>
+        <p:nvSpPr>
+          <p:cNvPr id="2" name="Slide Image Placeholder 1"/>
+          <p:cNvSpPr>
+            <a:spLocks noGrp="1"/>
+          </p:cNvSpPr>
+          <p:nvPr>
+            <p:ph type="sldImg" idx="2"/>
+          </p:nvPr>
+        </p:nvSpPr>
+        <p:spPr/>
+      </p:sp>
+      <p:sp>
+        <p:nvSpPr>
+          <p:cNvPr id="3" name="Notes Placeholder 2"/>
+          <p:cNvSpPr>
+            <a:spLocks noGrp="1"/>
+          </p:cNvSpPr>
+          <p:nvPr>
+            <p:ph type="body" idx="3" sz="quarter"/>
+          </p:nvPr>
+        </p:nvSpPr>
+        <p:spPr/>
+        <p:txBody>
+          <a:bodyPr/>
+          <a:lstStyle/>
+          <a:p>
+            <a:r>
+              <a:t>Объяснить, как управлять потоком выполнения программы.</a:t>
+            </a:r>
+          </a:p>
+        </p:txBody>
+      </p:sp>
+      <p:sp>
+        <p:nvSpPr>
+          <p:cNvPr id="4" name="Slide Number Placeholder 3"/>
+          <p:cNvSpPr>
+            <a:spLocks noGrp="1"/>
+          </p:cNvSpPr>
+          <p:nvPr>
+            <p:ph type="sldNum" idx="5" sz="quarter"/>
+          </p:nvPr>
+        </p:nvSpPr>
+        <p:spPr/>
+      </p:sp>
+    </p:spTree>
+  </p:cSld>
+  <p:clrMapOvr>
+    <a:masterClrMapping/>
+  </p:clrMapOvr>
+</p:notes>
+</file>
+
+<file path=ppt/notesSlides/notesSlide6.xml><?xml version="1.0" encoding="utf-8"?>
+<p:notes xmlns:a="http://schemas.openxmlformats.org/drawingml/2006/main" xmlns:p="http://schemas.openxmlformats.org/presentationml/2006/main" xmlns:r="http://schemas.openxmlformats.org/officeDocument/2006/relationships">
+  <p:cSld>
+    <p:spTree>
+      <p:nvGrpSpPr>
+        <p:cNvPr id="1" name=""/>
+        <p:cNvGrpSpPr/>
+        <p:nvPr/>
+      </p:nvGrpSpPr>
+      <p:grpSpPr>
+        <a:xfrm>
+          <a:off x="0" y="0"/>
+          <a:ext cx="0" cy="0"/>
+          <a:chOff x="0" y="0"/>
+          <a:chExt cx="0" cy="0"/>
+        </a:xfrm>
+      </p:grpSpPr>
+      <p:sp>
+        <p:nvSpPr>
+          <p:cNvPr id="2" name="Slide Image Placeholder 1"/>
+          <p:cNvSpPr>
+            <a:spLocks noGrp="1"/>
+          </p:cNvSpPr>
+          <p:nvPr>
+            <p:ph type="sldImg" idx="2"/>
+          </p:nvPr>
+        </p:nvSpPr>
+        <p:spPr/>
+      </p:sp>
+      <p:sp>
+        <p:nvSpPr>
+          <p:cNvPr id="3" name="Notes Placeholder 2"/>
+          <p:cNvSpPr>
+            <a:spLocks noGrp="1"/>
+          </p:cNvSpPr>
+          <p:nvPr>
+            <p:ph type="body" idx="3" sz="quarter"/>
+          </p:nvPr>
+        </p:nvSpPr>
+        <p:spPr/>
+        <p:txBody>
+          <a:bodyPr/>
+          <a:lstStyle/>
+          <a:p>
+            <a:r>
+              <a:t>Разобрать простые задачи на if-else.</a:t>
+            </a:r>
+          </a:p>
+        </p:txBody>
+      </p:sp>
+      <p:sp>
+        <p:nvSpPr>
+          <p:cNvPr id="4" name="Slide Number Placeholder 3"/>
+          <p:cNvSpPr>
+            <a:spLocks noGrp="1"/>
+          </p:cNvSpPr>
+          <p:nvPr>
+            <p:ph type="sldNum" idx="5" sz="quarter"/>
+          </p:nvPr>
+        </p:nvSpPr>
+        <p:spPr/>
+      </p:sp>
+    </p:spTree>
+  </p:cSld>
+  <p:clrMapOvr>
+    <a:masterClrMapping/>
+  </p:clrMapOvr>
+</p:notes>
+</file>
+
+<file path=ppt/notesSlides/notesSlide7.xml><?xml version="1.0" encoding="utf-8"?>
+<p:notes xmlns:a="http://schemas.openxmlformats.org/drawingml/2006/main" xmlns:p="http://schemas.openxmlformats.org/presentationml/2006/main" xmlns:r="http://schemas.openxmlformats.org/officeDocument/2006/relationships">
+  <p:cSld>
+    <p:spTree>
+      <p:nvGrpSpPr>
+        <p:cNvPr id="1" name=""/>
+        <p:cNvGrpSpPr/>
+        <p:nvPr/>
+      </p:nvGrpSpPr>
+      <p:grpSpPr>
+        <a:xfrm>
+          <a:off x="0" y="0"/>
+          <a:ext cx="0" cy="0"/>
+          <a:chOff x="0" y="0"/>
+          <a:chExt cx="0" cy="0"/>
+        </a:xfrm>
+      </p:grpSpPr>
+      <p:sp>
+        <p:nvSpPr>
+          <p:cNvPr id="2" name="Slide Image Placeholder 1"/>
+          <p:cNvSpPr>
+            <a:spLocks noGrp="1"/>
+          </p:cNvSpPr>
+          <p:nvPr>
+            <p:ph type="sldImg" idx="2"/>
+          </p:nvPr>
+        </p:nvSpPr>
+        <p:spPr/>
+      </p:sp>
+      <p:sp>
+        <p:nvSpPr>
+          <p:cNvPr id="3" name="Notes Placeholder 2"/>
+          <p:cNvSpPr>
+            <a:spLocks noGrp="1"/>
+          </p:cNvSpPr>
+          <p:nvPr>
+            <p:ph type="body" idx="3" sz="quarter"/>
+          </p:nvPr>
+        </p:nvSpPr>
+        <p:spPr/>
+        <p:txBody>
+          <a:bodyPr/>
+          <a:lstStyle/>
+          <a:p>
+            <a:r>
+              <a:t>Показать, как повторять действия в программе.</a:t>
+            </a:r>
+          </a:p>
+        </p:txBody>
+      </p:sp>
+      <p:sp>
+        <p:nvSpPr>
+          <p:cNvPr id="4" name="Slide Number Placeholder 3"/>
+          <p:cNvSpPr>
+            <a:spLocks noGrp="1"/>
+          </p:cNvSpPr>
+          <p:nvPr>
+            <p:ph type="sldNum" idx="5" sz="quarter"/>
+          </p:nvPr>
+        </p:nvSpPr>
+        <p:spPr/>
+      </p:sp>
+    </p:spTree>
+  </p:cSld>
+  <p:clrMapOvr>
+    <a:masterClrMapping/>
+  </p:clrMapOvr>
+</p:notes>
+</file>
+
+<file path=ppt/notesSlides/notesSlide8.xml><?xml version="1.0" encoding="utf-8"?>
+<p:notes xmlns:a="http://schemas.openxmlformats.org/drawingml/2006/main" xmlns:p="http://schemas.openxmlformats.org/presentationml/2006/main" xmlns:r="http://schemas.openxmlformats.org/officeDocument/2006/relationships">
+  <p:cSld>
+    <p:spTree>
+      <p:nvGrpSpPr>
+        <p:cNvPr id="1" name=""/>
+        <p:cNvGrpSpPr/>
+        <p:nvPr/>
+      </p:nvGrpSpPr>
+      <p:grpSpPr>
+        <a:xfrm>
+          <a:off x="0" y="0"/>
+          <a:ext cx="0" cy="0"/>
+          <a:chOff x="0" y="0"/>
+          <a:chExt cx="0" cy="0"/>
+        </a:xfrm>
+      </p:grpSpPr>
+      <p:sp>
+        <p:nvSpPr>
+          <p:cNvPr id="2" name="Slide Image Placeholder 1"/>
+          <p:cNvSpPr>
+            <a:spLocks noGrp="1"/>
+          </p:cNvSpPr>
+          <p:nvPr>
+            <p:ph type="sldImg" idx="2"/>
+          </p:nvPr>
+        </p:nvSpPr>
+        <p:spPr/>
+      </p:sp>
+      <p:sp>
+        <p:nvSpPr>
+          <p:cNvPr id="3" name="Notes Placeholder 2"/>
+          <p:cNvSpPr>
+            <a:spLocks noGrp="1"/>
+          </p:cNvSpPr>
+          <p:nvPr>
+            <p:ph type="body" idx="3" sz="quarter"/>
+          </p:nvPr>
+        </p:nvSpPr>
+        <p:spPr/>
+        <p:txBody>
+          <a:bodyPr/>
+          <a:lstStyle/>
+          <a:p>
+            <a:r>
+              <a:t>Кратко рассказать о списках и их методах.</a:t>
+            </a:r>
+          </a:p>
+        </p:txBody>
+      </p:sp>
+      <p:sp>
+        <p:nvSpPr>
+          <p:cNvPr id="4" name="Slide Number Placeholder 3"/>
+          <p:cNvSpPr>
+            <a:spLocks noGrp="1"/>
+          </p:cNvSpPr>
+          <p:nvPr>
+            <p:ph type="sldNum" idx="5" sz="quarter"/>
+          </p:nvPr>
+        </p:nvSpPr>
+        <p:spPr/>
+      </p:sp>
+    </p:spTree>
+  </p:cSld>
+  <p:clrMapOvr>
+    <a:masterClrMapping/>
+  </p:clrMapOvr>
+</p:notes>
+</file>
+
+<file path=ppt/notesSlides/notesSlide9.xml><?xml version="1.0" encoding="utf-8"?>
+<p:notes xmlns:a="http://schemas.openxmlformats.org/drawingml/2006/main" xmlns:p="http://schemas.openxmlformats.org/presentationml/2006/main" xmlns:r="http://schemas.openxmlformats.org/officeDocument/2006/relationships">
+  <p:cSld>
+    <p:spTree>
+      <p:nvGrpSpPr>
+        <p:cNvPr id="1" name=""/>
+        <p:cNvGrpSpPr/>
+        <p:nvPr/>
+      </p:nvGrpSpPr>
+      <p:grpSpPr>
+        <a:xfrm>
+          <a:off x="0" y="0"/>
+          <a:ext cx="0" cy="0"/>
+          <a:chOff x="0" y="0"/>
+          <a:chExt cx="0" cy="0"/>
+        </a:xfrm>
+      </p:grpSpPr>
+      <p:sp>
+        <p:nvSpPr>
+          <p:cNvPr id="2" name="Slide Image Placeholder 1"/>
+          <p:cNvSpPr>
+            <a:spLocks noGrp="1"/>
+          </p:cNvSpPr>
+          <p:nvPr>
+            <p:ph type="sldImg" idx="2"/>
+          </p:nvPr>
+        </p:nvSpPr>
+        <p:spPr/>
+      </p:sp>
+      <p:sp>
+        <p:nvSpPr>
+          <p:cNvPr id="3" name="Notes Placeholder 2"/>
+          <p:cNvSpPr>
+            <a:spLocks noGrp="1"/>
+          </p:cNvSpPr>
+          <p:nvPr>
+            <p:ph type="body" idx="3" sz="quarter"/>
+          </p:nvPr>
+        </p:nvSpPr>
+        <p:spPr/>
+        <p:txBody>
+          <a:bodyPr/>
+          <a:lstStyle/>
+          <a:p>
+            <a:r>
+              <a:t>Объяснить, как писать и вызывать функции.</a:t>
             </a:r>
           </a:p>
         </p:txBody>
@@ -3515,37 +4154,662 @@
             <a:spLocks noGrp="1"/>
           </p:cNvSpPr>
           <p:nvPr>
-            <p:ph type="ctrTitle"/>
-          </p:nvPr>
-        </p:nvSpPr>
-        <p:spPr/>
-        <p:txBody>
-          <a:bodyPr/>
-          <a:lstStyle/>
-          <a:p>
-            <a:r>
-              <a:t>Первые шаги в Python</a:t>
-            </a:r>
-          </a:p>
-        </p:txBody>
-      </p:sp>
-      <p:sp>
-        <p:nvSpPr>
-          <p:cNvPr id="3" name="Subtitle 2"/>
-          <p:cNvSpPr>
-            <a:spLocks noGrp="1"/>
-          </p:cNvSpPr>
-          <p:nvPr>
-            <p:ph type="subTitle" idx="1"/>
-          </p:nvPr>
-        </p:nvSpPr>
-        <p:spPr/>
-        <p:txBody>
-          <a:bodyPr/>
-          <a:lstStyle/>
-          <a:p>
-            <a:r>
-              <a:t>[Слайды не сформированы моделью]</a:t>
+            <p:ph type="title"/>
+          </p:nvPr>
+        </p:nvSpPr>
+        <p:spPr/>
+        <p:txBody>
+          <a:bodyPr/>
+          <a:lstStyle/>
+          <a:p>
+            <a:r>
+              <a:t>О чём этот курс?</a:t>
+            </a:r>
+          </a:p>
+        </p:txBody>
+      </p:sp>
+      <p:sp>
+        <p:nvSpPr>
+          <p:cNvPr id="3" name="Content Placeholder 2"/>
+          <p:cNvSpPr>
+            <a:spLocks noGrp="1"/>
+          </p:cNvSpPr>
+          <p:nvPr>
+            <p:ph idx="1"/>
+          </p:nvPr>
+        </p:nvSpPr>
+        <p:spPr/>
+        <p:txBody>
+          <a:bodyPr/>
+          <a:lstStyle/>
+          <a:p>
+            <a:r>
+              <a:t>Python — простой и мощный язык программирования</a:t>
+            </a:r>
+          </a:p>
+          <a:p>
+            <a:r>
+              <a:t>Используется в науке, веб-разработке, анализе данных, автоматизации</a:t>
+            </a:r>
+          </a:p>
+        </p:txBody>
+      </p:sp>
+    </p:spTree>
+  </p:cSld>
+  <p:clrMapOvr>
+    <a:masterClrMapping/>
+  </p:clrMapOvr>
+</p:sld>
+</file>
+
+<file path=ppt/slides/slide10.xml><?xml version="1.0" encoding="utf-8"?>
+<p:sld xmlns:a="http://schemas.openxmlformats.org/drawingml/2006/main" xmlns:p="http://schemas.openxmlformats.org/presentationml/2006/main" xmlns:r="http://schemas.openxmlformats.org/officeDocument/2006/relationships">
+  <p:cSld>
+    <p:spTree>
+      <p:nvGrpSpPr>
+        <p:cNvPr id="1" name=""/>
+        <p:cNvGrpSpPr/>
+        <p:nvPr/>
+      </p:nvGrpSpPr>
+      <p:grpSpPr/>
+      <p:sp>
+        <p:nvSpPr>
+          <p:cNvPr id="2" name="Title 1"/>
+          <p:cNvSpPr>
+            <a:spLocks noGrp="1"/>
+          </p:cNvSpPr>
+          <p:nvPr>
+            <p:ph type="title"/>
+          </p:nvPr>
+        </p:nvSpPr>
+        <p:spPr/>
+        <p:txBody>
+          <a:bodyPr/>
+          <a:lstStyle/>
+          <a:p>
+            <a:r>
+              <a:t>Практика и самопроверка</a:t>
+            </a:r>
+          </a:p>
+        </p:txBody>
+      </p:sp>
+      <p:sp>
+        <p:nvSpPr>
+          <p:cNvPr id="3" name="Content Placeholder 2"/>
+          <p:cNvSpPr>
+            <a:spLocks noGrp="1"/>
+          </p:cNvSpPr>
+          <p:nvPr>
+            <p:ph idx="1"/>
+          </p:nvPr>
+        </p:nvSpPr>
+        <p:spPr/>
+        <p:txBody>
+          <a:bodyPr/>
+          <a:lstStyle/>
+          <a:p>
+            <a:r>
+              <a:t>Написать программу: ввод числа, проверка на чётность, вывод результата</a:t>
+            </a:r>
+          </a:p>
+          <a:p>
+            <a:r>
+              <a:t>Создать функцию для приветствия пользователя</a:t>
+            </a:r>
+          </a:p>
+          <a:p>
+            <a:r>
+              <a:t>Использовать цикл для вывода чисел от 1 до 10</a:t>
+            </a:r>
+          </a:p>
+        </p:txBody>
+      </p:sp>
+    </p:spTree>
+  </p:cSld>
+  <p:clrMapOvr>
+    <a:masterClrMapping/>
+  </p:clrMapOvr>
+</p:sld>
+</file>
+
+<file path=ppt/slides/slide2.xml><?xml version="1.0" encoding="utf-8"?>
+<p:sld xmlns:a="http://schemas.openxmlformats.org/drawingml/2006/main" xmlns:p="http://schemas.openxmlformats.org/presentationml/2006/main" xmlns:r="http://schemas.openxmlformats.org/officeDocument/2006/relationships">
+  <p:cSld>
+    <p:spTree>
+      <p:nvGrpSpPr>
+        <p:cNvPr id="1" name=""/>
+        <p:cNvGrpSpPr/>
+        <p:nvPr/>
+      </p:nvGrpSpPr>
+      <p:grpSpPr/>
+      <p:sp>
+        <p:nvSpPr>
+          <p:cNvPr id="2" name="Title 1"/>
+          <p:cNvSpPr>
+            <a:spLocks noGrp="1"/>
+          </p:cNvSpPr>
+          <p:nvPr>
+            <p:ph type="title"/>
+          </p:nvPr>
+        </p:nvSpPr>
+        <p:spPr/>
+        <p:txBody>
+          <a:bodyPr/>
+          <a:lstStyle/>
+          <a:p>
+            <a:r>
+              <a:t>Установка Python и первая программа</a:t>
+            </a:r>
+          </a:p>
+        </p:txBody>
+      </p:sp>
+      <p:sp>
+        <p:nvSpPr>
+          <p:cNvPr id="3" name="Content Placeholder 2"/>
+          <p:cNvSpPr>
+            <a:spLocks noGrp="1"/>
+          </p:cNvSpPr>
+          <p:nvPr>
+            <p:ph idx="1"/>
+          </p:nvPr>
+        </p:nvSpPr>
+        <p:spPr/>
+        <p:txBody>
+          <a:bodyPr/>
+          <a:lstStyle/>
+          <a:p>
+            <a:r>
+              <a:t>Скачиваем Python с официального сайта python.org</a:t>
+            </a:r>
+          </a:p>
+          <a:p>
+            <a:r>
+              <a:t>Устанавливаем, выбирая опцию 'Add Python to PATH'</a:t>
+            </a:r>
+          </a:p>
+          <a:p>
+            <a:r>
+              <a:t>Пишем первую программу: print('Hello, World!')</a:t>
+            </a:r>
+          </a:p>
+        </p:txBody>
+      </p:sp>
+    </p:spTree>
+  </p:cSld>
+  <p:clrMapOvr>
+    <a:masterClrMapping/>
+  </p:clrMapOvr>
+</p:sld>
+</file>
+
+<file path=ppt/slides/slide3.xml><?xml version="1.0" encoding="utf-8"?>
+<p:sld xmlns:a="http://schemas.openxmlformats.org/drawingml/2006/main" xmlns:p="http://schemas.openxmlformats.org/presentationml/2006/main" xmlns:r="http://schemas.openxmlformats.org/officeDocument/2006/relationships">
+  <p:cSld>
+    <p:spTree>
+      <p:nvGrpSpPr>
+        <p:cNvPr id="1" name=""/>
+        <p:cNvGrpSpPr/>
+        <p:nvPr/>
+      </p:nvGrpSpPr>
+      <p:grpSpPr/>
+      <p:sp>
+        <p:nvSpPr>
+          <p:cNvPr id="2" name="Title 1"/>
+          <p:cNvSpPr>
+            <a:spLocks noGrp="1"/>
+          </p:cNvSpPr>
+          <p:nvPr>
+            <p:ph type="title"/>
+          </p:nvPr>
+        </p:nvSpPr>
+        <p:spPr/>
+        <p:txBody>
+          <a:bodyPr/>
+          <a:lstStyle/>
+          <a:p>
+            <a:r>
+              <a:t>Переменные и базовые типы данных</a:t>
+            </a:r>
+          </a:p>
+        </p:txBody>
+      </p:sp>
+      <p:sp>
+        <p:nvSpPr>
+          <p:cNvPr id="3" name="Content Placeholder 2"/>
+          <p:cNvSpPr>
+            <a:spLocks noGrp="1"/>
+          </p:cNvSpPr>
+          <p:nvPr>
+            <p:ph idx="1"/>
+          </p:nvPr>
+        </p:nvSpPr>
+        <p:spPr/>
+        <p:txBody>
+          <a:bodyPr/>
+          <a:lstStyle/>
+          <a:p>
+            <a:r>
+              <a:t>Переменная — именованное место для хранения данных</a:t>
+            </a:r>
+          </a:p>
+          <a:p>
+            <a:r>
+              <a:t>Основные типы: int, float, str, bool</a:t>
+            </a:r>
+          </a:p>
+          <a:p>
+            <a:r>
+              <a:t>Примеры: x = 10, y = 3.14, name = 'Python', is_active = True</a:t>
+            </a:r>
+          </a:p>
+        </p:txBody>
+      </p:sp>
+    </p:spTree>
+  </p:cSld>
+  <p:clrMapOvr>
+    <a:masterClrMapping/>
+  </p:clrMapOvr>
+</p:sld>
+</file>
+
+<file path=ppt/slides/slide4.xml><?xml version="1.0" encoding="utf-8"?>
+<p:sld xmlns:a="http://schemas.openxmlformats.org/drawingml/2006/main" xmlns:p="http://schemas.openxmlformats.org/presentationml/2006/main" xmlns:r="http://schemas.openxmlformats.org/officeDocument/2006/relationships">
+  <p:cSld>
+    <p:spTree>
+      <p:nvGrpSpPr>
+        <p:cNvPr id="1" name=""/>
+        <p:cNvGrpSpPr/>
+        <p:nvPr/>
+      </p:nvGrpSpPr>
+      <p:grpSpPr/>
+      <p:sp>
+        <p:nvSpPr>
+          <p:cNvPr id="2" name="Title 1"/>
+          <p:cNvSpPr>
+            <a:spLocks noGrp="1"/>
+          </p:cNvSpPr>
+          <p:nvPr>
+            <p:ph type="title"/>
+          </p:nvPr>
+        </p:nvSpPr>
+        <p:spPr/>
+        <p:txBody>
+          <a:bodyPr/>
+          <a:lstStyle/>
+          <a:p>
+            <a:r>
+              <a:t>Ввод и вывод данных</a:t>
+            </a:r>
+          </a:p>
+        </p:txBody>
+      </p:sp>
+      <p:sp>
+        <p:nvSpPr>
+          <p:cNvPr id="3" name="Content Placeholder 2"/>
+          <p:cNvSpPr>
+            <a:spLocks noGrp="1"/>
+          </p:cNvSpPr>
+          <p:nvPr>
+            <p:ph idx="1"/>
+          </p:nvPr>
+        </p:nvSpPr>
+        <p:spPr/>
+        <p:txBody>
+          <a:bodyPr/>
+          <a:lstStyle/>
+          <a:p>
+            <a:r>
+              <a:t>Вывод: print('Текст')</a:t>
+            </a:r>
+          </a:p>
+          <a:p>
+            <a:r>
+              <a:t>Ввод: name = input('Введите имя: ')</a:t>
+            </a:r>
+          </a:p>
+          <a:p>
+            <a:r>
+              <a:t>Пример: print('Привет,', name)</a:t>
+            </a:r>
+          </a:p>
+        </p:txBody>
+      </p:sp>
+    </p:spTree>
+  </p:cSld>
+  <p:clrMapOvr>
+    <a:masterClrMapping/>
+  </p:clrMapOvr>
+</p:sld>
+</file>
+
+<file path=ppt/slides/slide5.xml><?xml version="1.0" encoding="utf-8"?>
+<p:sld xmlns:a="http://schemas.openxmlformats.org/drawingml/2006/main" xmlns:p="http://schemas.openxmlformats.org/presentationml/2006/main" xmlns:r="http://schemas.openxmlformats.org/officeDocument/2006/relationships">
+  <p:cSld>
+    <p:spTree>
+      <p:nvGrpSpPr>
+        <p:cNvPr id="1" name=""/>
+        <p:cNvGrpSpPr/>
+        <p:nvPr/>
+      </p:nvGrpSpPr>
+      <p:grpSpPr/>
+      <p:sp>
+        <p:nvSpPr>
+          <p:cNvPr id="2" name="Title 1"/>
+          <p:cNvSpPr>
+            <a:spLocks noGrp="1"/>
+          </p:cNvSpPr>
+          <p:nvPr>
+            <p:ph type="title"/>
+          </p:nvPr>
+        </p:nvSpPr>
+        <p:spPr/>
+        <p:txBody>
+          <a:bodyPr/>
+          <a:lstStyle/>
+          <a:p>
+            <a:r>
+              <a:t>Условные операторы</a:t>
+            </a:r>
+          </a:p>
+        </p:txBody>
+      </p:sp>
+      <p:sp>
+        <p:nvSpPr>
+          <p:cNvPr id="3" name="Content Placeholder 2"/>
+          <p:cNvSpPr>
+            <a:spLocks noGrp="1"/>
+          </p:cNvSpPr>
+          <p:nvPr>
+            <p:ph idx="1"/>
+          </p:nvPr>
+        </p:nvSpPr>
+        <p:spPr/>
+        <p:txBody>
+          <a:bodyPr/>
+          <a:lstStyle/>
+          <a:p>
+            <a:r>
+              <a:t>if — if условие:</a:t>
+            </a:r>
+          </a:p>
+          <a:p>
+            <a:r>
+              <a:t>else — else:</a:t>
+            </a:r>
+          </a:p>
+          <a:p>
+            <a:r>
+              <a:t>elif — elif условие:</a:t>
+            </a:r>
+          </a:p>
+          <a:p>
+            <a:r>
+              <a:t>Пример: if x &gt; 0: print('Положительное')</a:t>
+            </a:r>
+          </a:p>
+        </p:txBody>
+      </p:sp>
+    </p:spTree>
+  </p:cSld>
+  <p:clrMapOvr>
+    <a:masterClrMapping/>
+  </p:clrMapOvr>
+</p:sld>
+</file>
+
+<file path=ppt/slides/slide6.xml><?xml version="1.0" encoding="utf-8"?>
+<p:sld xmlns:a="http://schemas.openxmlformats.org/drawingml/2006/main" xmlns:p="http://schemas.openxmlformats.org/presentationml/2006/main" xmlns:r="http://schemas.openxmlformats.org/officeDocument/2006/relationships">
+  <p:cSld>
+    <p:spTree>
+      <p:nvGrpSpPr>
+        <p:cNvPr id="1" name=""/>
+        <p:cNvGrpSpPr/>
+        <p:nvPr/>
+      </p:nvGrpSpPr>
+      <p:grpSpPr/>
+      <p:sp>
+        <p:nvSpPr>
+          <p:cNvPr id="2" name="Title 1"/>
+          <p:cNvSpPr>
+            <a:spLocks noGrp="1"/>
+          </p:cNvSpPr>
+          <p:nvPr>
+            <p:ph type="title"/>
+          </p:nvPr>
+        </p:nvSpPr>
+        <p:spPr/>
+        <p:txBody>
+          <a:bodyPr/>
+          <a:lstStyle/>
+          <a:p>
+            <a:r>
+              <a:t>Примеры с ветвлением</a:t>
+            </a:r>
+          </a:p>
+        </p:txBody>
+      </p:sp>
+      <p:sp>
+        <p:nvSpPr>
+          <p:cNvPr id="3" name="Content Placeholder 2"/>
+          <p:cNvSpPr>
+            <a:spLocks noGrp="1"/>
+          </p:cNvSpPr>
+          <p:nvPr>
+            <p:ph idx="1"/>
+          </p:nvPr>
+        </p:nvSpPr>
+        <p:spPr/>
+        <p:txBody>
+          <a:bodyPr/>
+          <a:lstStyle/>
+          <a:p>
+            <a:r>
+              <a:t>Проверка возраста: if age &gt;= 18: print('Взрослый')</a:t>
+            </a:r>
+          </a:p>
+          <a:p>
+            <a:r>
+              <a:t>Проверка на чётность: if x % 2 == 0: print('Чётное')</a:t>
+            </a:r>
+          </a:p>
+        </p:txBody>
+      </p:sp>
+    </p:spTree>
+  </p:cSld>
+  <p:clrMapOvr>
+    <a:masterClrMapping/>
+  </p:clrMapOvr>
+</p:sld>
+</file>
+
+<file path=ppt/slides/slide7.xml><?xml version="1.0" encoding="utf-8"?>
+<p:sld xmlns:a="http://schemas.openxmlformats.org/drawingml/2006/main" xmlns:p="http://schemas.openxmlformats.org/presentationml/2006/main" xmlns:r="http://schemas.openxmlformats.org/officeDocument/2006/relationships">
+  <p:cSld>
+    <p:spTree>
+      <p:nvGrpSpPr>
+        <p:cNvPr id="1" name=""/>
+        <p:cNvGrpSpPr/>
+        <p:nvPr/>
+      </p:nvGrpSpPr>
+      <p:grpSpPr/>
+      <p:sp>
+        <p:nvSpPr>
+          <p:cNvPr id="2" name="Title 1"/>
+          <p:cNvSpPr>
+            <a:spLocks noGrp="1"/>
+          </p:cNvSpPr>
+          <p:nvPr>
+            <p:ph type="title"/>
+          </p:nvPr>
+        </p:nvSpPr>
+        <p:spPr/>
+        <p:txBody>
+          <a:bodyPr/>
+          <a:lstStyle/>
+          <a:p>
+            <a:r>
+              <a:t>Циклы: for и while</a:t>
+            </a:r>
+          </a:p>
+        </p:txBody>
+      </p:sp>
+      <p:sp>
+        <p:nvSpPr>
+          <p:cNvPr id="3" name="Content Placeholder 2"/>
+          <p:cNvSpPr>
+            <a:spLocks noGrp="1"/>
+          </p:cNvSpPr>
+          <p:nvPr>
+            <p:ph idx="1"/>
+          </p:nvPr>
+        </p:nvSpPr>
+        <p:spPr/>
+        <p:txBody>
+          <a:bodyPr/>
+          <a:lstStyle/>
+          <a:p>
+            <a:r>
+              <a:t>for i in range(5): print(i)</a:t>
+            </a:r>
+          </a:p>
+          <a:p>
+            <a:r>
+              <a:t>while x &lt; 10: print(x); x += 1</a:t>
+            </a:r>
+          </a:p>
+        </p:txBody>
+      </p:sp>
+    </p:spTree>
+  </p:cSld>
+  <p:clrMapOvr>
+    <a:masterClrMapping/>
+  </p:clrMapOvr>
+</p:sld>
+</file>
+
+<file path=ppt/slides/slide8.xml><?xml version="1.0" encoding="utf-8"?>
+<p:sld xmlns:a="http://schemas.openxmlformats.org/drawingml/2006/main" xmlns:p="http://schemas.openxmlformats.org/presentationml/2006/main" xmlns:r="http://schemas.openxmlformats.org/officeDocument/2006/relationships">
+  <p:cSld>
+    <p:spTree>
+      <p:nvGrpSpPr>
+        <p:cNvPr id="1" name=""/>
+        <p:cNvGrpSpPr/>
+        <p:nvPr/>
+      </p:nvGrpSpPr>
+      <p:grpSpPr/>
+      <p:sp>
+        <p:nvSpPr>
+          <p:cNvPr id="2" name="Title 1"/>
+          <p:cNvSpPr>
+            <a:spLocks noGrp="1"/>
+          </p:cNvSpPr>
+          <p:nvPr>
+            <p:ph type="title"/>
+          </p:nvPr>
+        </p:nvSpPr>
+        <p:spPr/>
+        <p:txBody>
+          <a:bodyPr/>
+          <a:lstStyle/>
+          <a:p>
+            <a:r>
+              <a:t>Списки и работа с ними</a:t>
+            </a:r>
+          </a:p>
+        </p:txBody>
+      </p:sp>
+      <p:sp>
+        <p:nvSpPr>
+          <p:cNvPr id="3" name="Content Placeholder 2"/>
+          <p:cNvSpPr>
+            <a:spLocks noGrp="1"/>
+          </p:cNvSpPr>
+          <p:nvPr>
+            <p:ph idx="1"/>
+          </p:nvPr>
+        </p:nvSpPr>
+        <p:spPr/>
+        <p:txBody>
+          <a:bodyPr/>
+          <a:lstStyle/>
+          <a:p>
+            <a:r>
+              <a:t>Список — упорядоченная коллекция данных</a:t>
+            </a:r>
+          </a:p>
+          <a:p>
+            <a:r>
+              <a:t>Методы: append(), remove(), len(), for item in items:</a:t>
+            </a:r>
+          </a:p>
+        </p:txBody>
+      </p:sp>
+    </p:spTree>
+  </p:cSld>
+  <p:clrMapOvr>
+    <a:masterClrMapping/>
+  </p:clrMapOvr>
+</p:sld>
+</file>
+
+<file path=ppt/slides/slide9.xml><?xml version="1.0" encoding="utf-8"?>
+<p:sld xmlns:a="http://schemas.openxmlformats.org/drawingml/2006/main" xmlns:p="http://schemas.openxmlformats.org/presentationml/2006/main" xmlns:r="http://schemas.openxmlformats.org/officeDocument/2006/relationships">
+  <p:cSld>
+    <p:spTree>
+      <p:nvGrpSpPr>
+        <p:cNvPr id="1" name=""/>
+        <p:cNvGrpSpPr/>
+        <p:nvPr/>
+      </p:nvGrpSpPr>
+      <p:grpSpPr/>
+      <p:sp>
+        <p:nvSpPr>
+          <p:cNvPr id="2" name="Title 1"/>
+          <p:cNvSpPr>
+            <a:spLocks noGrp="1"/>
+          </p:cNvSpPr>
+          <p:nvPr>
+            <p:ph type="title"/>
+          </p:nvPr>
+        </p:nvSpPr>
+        <p:spPr/>
+        <p:txBody>
+          <a:bodyPr/>
+          <a:lstStyle/>
+          <a:p>
+            <a:r>
+              <a:t>Функции: создание и использование</a:t>
+            </a:r>
+          </a:p>
+        </p:txBody>
+      </p:sp>
+      <p:sp>
+        <p:nvSpPr>
+          <p:cNvPr id="3" name="Content Placeholder 2"/>
+          <p:cNvSpPr>
+            <a:spLocks noGrp="1"/>
+          </p:cNvSpPr>
+          <p:nvPr>
+            <p:ph idx="1"/>
+          </p:nvPr>
+        </p:nvSpPr>
+        <p:spPr/>
+        <p:txBody>
+          <a:bodyPr/>
+          <a:lstStyle/>
+          <a:p>
+            <a:r>
+              <a:t>def имя_функции(параметры):</a:t>
+            </a:r>
+          </a:p>
+          <a:p>
+            <a:r>
+              <a:t>return результат</a:t>
+            </a:r>
+          </a:p>
+          <a:p>
+            <a:r>
+              <a:t>Пример: def greet(name): return 'Привет,' + name</a:t>
             </a:r>
           </a:p>
         </p:txBody>

</xml_diff>

<commit_message>
feat: complete plan — official checklists, lite persistence, web progress and gateway limits
</commit_message>
<xml_diff>
--- a/examples/tk1/presentation_tk1.pptx
+++ b/examples/tk1/presentation_tk1.pptx
@@ -15,6 +15,7 @@
     <p:sldId id="263" r:id="rId15"/>
     <p:sldId id="264" r:id="rId16"/>
     <p:sldId id="265" r:id="rId17"/>
+    <p:sldId id="266" r:id="rId18"/>
   </p:sldIdLst>
   <p:sldSz cx="9144000" cy="6858000" type="screen4x3"/>
   <p:notesSz cx="6858000" cy="9144000"/>
@@ -582,6 +583,76 @@
           <a:p>
             <a:r>
               <a:t>Дать задания для закрепления материала.</a:t>
+            </a:r>
+          </a:p>
+        </p:txBody>
+      </p:sp>
+      <p:sp>
+        <p:nvSpPr>
+          <p:cNvPr id="4" name="Slide Number Placeholder 3"/>
+          <p:cNvSpPr>
+            <a:spLocks noGrp="1"/>
+          </p:cNvSpPr>
+          <p:nvPr>
+            <p:ph type="sldNum" idx="5" sz="quarter"/>
+          </p:nvPr>
+        </p:nvSpPr>
+        <p:spPr/>
+      </p:sp>
+    </p:spTree>
+  </p:cSld>
+  <p:clrMapOvr>
+    <a:masterClrMapping/>
+  </p:clrMapOvr>
+</p:notes>
+</file>
+
+<file path=ppt/notesSlides/notesSlide11.xml><?xml version="1.0" encoding="utf-8"?>
+<p:notes xmlns:a="http://schemas.openxmlformats.org/drawingml/2006/main" xmlns:p="http://schemas.openxmlformats.org/presentationml/2006/main" xmlns:r="http://schemas.openxmlformats.org/officeDocument/2006/relationships">
+  <p:cSld>
+    <p:spTree>
+      <p:nvGrpSpPr>
+        <p:cNvPr id="1" name=""/>
+        <p:cNvGrpSpPr/>
+        <p:nvPr/>
+      </p:nvGrpSpPr>
+      <p:grpSpPr>
+        <a:xfrm>
+          <a:off x="0" y="0"/>
+          <a:ext cx="0" cy="0"/>
+          <a:chOff x="0" y="0"/>
+          <a:chExt cx="0" cy="0"/>
+        </a:xfrm>
+      </p:grpSpPr>
+      <p:sp>
+        <p:nvSpPr>
+          <p:cNvPr id="2" name="Slide Image Placeholder 1"/>
+          <p:cNvSpPr>
+            <a:spLocks noGrp="1"/>
+          </p:cNvSpPr>
+          <p:nvPr>
+            <p:ph type="sldImg" idx="2"/>
+          </p:nvPr>
+        </p:nvSpPr>
+        <p:spPr/>
+      </p:sp>
+      <p:sp>
+        <p:nvSpPr>
+          <p:cNvPr id="3" name="Notes Placeholder 2"/>
+          <p:cNvSpPr>
+            <a:spLocks noGrp="1"/>
+          </p:cNvSpPr>
+          <p:nvPr>
+            <p:ph type="body" idx="3" sz="quarter"/>
+          </p:nvPr>
+        </p:nvSpPr>
+        <p:spPr/>
+        <p:txBody>
+          <a:bodyPr/>
+          <a:lstStyle/>
+          <a:p>
+            <a:r>
+              <a:t>Слайд собран из темы и результатов обучения (S13 не вернул отдельный блок).</a:t>
             </a:r>
           </a:p>
         </p:txBody>
@@ -4260,6 +4331,71 @@
           <a:p>
             <a:r>
               <a:t>Использовать цикл для вывода чисел от 1 до 10</a:t>
+            </a:r>
+          </a:p>
+        </p:txBody>
+      </p:sp>
+    </p:spTree>
+  </p:cSld>
+  <p:clrMapOvr>
+    <a:masterClrMapping/>
+  </p:clrMapOvr>
+</p:sld>
+</file>
+
+<file path=ppt/slides/slide11.xml><?xml version="1.0" encoding="utf-8"?>
+<p:sld xmlns:a="http://schemas.openxmlformats.org/drawingml/2006/main" xmlns:p="http://schemas.openxmlformats.org/presentationml/2006/main" xmlns:r="http://schemas.openxmlformats.org/officeDocument/2006/relationships">
+  <p:cSld>
+    <p:spTree>
+      <p:nvGrpSpPr>
+        <p:cNvPr id="1" name=""/>
+        <p:cNvGrpSpPr/>
+        <p:nvPr/>
+      </p:nvGrpSpPr>
+      <p:grpSpPr/>
+      <p:sp>
+        <p:nvSpPr>
+          <p:cNvPr id="2" name="Title 1"/>
+          <p:cNvSpPr>
+            <a:spLocks noGrp="1"/>
+          </p:cNvSpPr>
+          <p:nvPr>
+            <p:ph type="title"/>
+          </p:nvPr>
+        </p:nvSpPr>
+        <p:spPr/>
+        <p:txBody>
+          <a:bodyPr/>
+          <a:lstStyle/>
+          <a:p>
+            <a:r>
+              <a:t>Алгоритмы: последовательность, ветвление, цикл</a:t>
+            </a:r>
+          </a:p>
+        </p:txBody>
+      </p:sp>
+      <p:sp>
+        <p:nvSpPr>
+          <p:cNvPr id="3" name="Content Placeholder 2"/>
+          <p:cNvSpPr>
+            <a:spLocks noGrp="1"/>
+          </p:cNvSpPr>
+          <p:nvPr>
+            <p:ph idx="1"/>
+          </p:nvPr>
+        </p:nvSpPr>
+        <p:spPr/>
+        <p:txBody>
+          <a:bodyPr/>
+          <a:lstStyle/>
+          <a:p>
+            <a:r>
+              <a:t>Знает основные алгоритмические конструкции: последовательность, ветвление, цикл.</a:t>
+            </a:r>
+          </a:p>
+          <a:p>
+            <a:r>
+              <a:t>Умеет составлять алгоритмы для решения типовых задач и преобразовывать их в программный код.</a:t>
             </a:r>
           </a:p>
         </p:txBody>

</xml_diff>